<commit_message>
One-hour format: dedicated instance, one entity and one user per seat
The one-hour workshop now runs in a /IOTCONNECT instance created for the
event. The template, the five AI Models and the dashboard artwork live at
the root; each seat is an entity named user-N holding one pre-created
device (ek-ra8p1-NN), one user login (user-N) and one dashboard, so an
attendee sees exactly one board and cannot deploy to anyone else's.

The one-hour facilitator guide describes the instance layout, the prep
steps in order (with an isolation check from a seat login before the rest
of the boards are provisioned), a shorter seat card, and how to retire the
instance afterwards. The attendee guide, the workshop index, the
presentation notes and the one-hour deck (slides 3, 8 and 9 plus notes)
follow the same model.
</commit_message>
<xml_diff>
--- a/docs/workshop/EK-RA8P1-workshop-deck-1-hour.pptx
+++ b/docs/workshop/EK-RA8P1-workshop-deck-1-hour.pptx
@@ -576,7 +576,7 @@
           <a:lstStyle/>
           <a:p>
             <a:r>
-              <a:t>Welcome. Plug in now: Ethernet first, then USB-C to DEBUG1. The boards are already provisioned, so they connect to the cloud while we talk. Everyone should have a board, an LCD, two cables and a seat card; the seat number on the card matches the sticker on the board. The Wi-Fi details and the console URL are on the whiteboard. Ten minutes of talking, forty-five at your board, five to close.</a:t>
+              <a:t>Welcome. Plug in now: Ethernet first, then USB-C to DEBUG1. The boards are already provisioned into a workshop instance built for today, one entity per seat, so they connect to the cloud while we talk. Everyone should have a board, an LCD, two cables and a seat card; the seat number on the card matches the sticker on the board. The Wi-Fi details and the console URL are on the whiteboard. Ten minutes of talking, forty-five at your board, five to close.</a:t>
             </a:r>
           </a:p>
         </p:txBody>
@@ -926,7 +926,7 @@
           <a:lstStyle/>
           <a:p>
             <a:r>
-              <a:t>Say which card applies before anyone stands up. If boards are collected, the erase matters only if attendees opened a console; otherwise the facilitator erases later. If boards go home, remind people the account is temporary and the Quickstart covers making their own. Collect seat cards; they carry a login.</a:t>
+              <a:t>Say which card applies before anyone stands up. If boards are collected, the facilitator erases the identities afterwards and retires the workshop instance. If boards go home, remind people the workshop instance is temporary and the Quickstart covers making their own account. Collect seat cards; they carry a login and a password.</a:t>
             </a:r>
           </a:p>
         </p:txBody>
@@ -1136,7 +1136,7 @@
           <a:lstStyle/>
           <a:p>
             <a:r>
-              <a:t>Point at each item. The boards were provisioned before the session, so nobody types a certificate today. USB-C powers the board; the serial console on the same port is optional and only for people who want to see the log. The seat card is the source of truth: device ID, dashboard name, login.</a:t>
+              <a:t>Point at each item. The boards were provisioned before the session, so nobody types a certificate today. USB-C powers the board; the serial console on the same port is optional and only for people who want to see the log. Each seat has its own entity in the workshop instance with one device and one user in it, so a login sees only its own board: there is no way to deploy to a neighbour.</a:t>
             </a:r>
           </a:p>
         </p:txBody>
@@ -1486,7 +1486,7 @@
           <a:lstStyle/>
           <a:p>
             <a:r>
-              <a:t>Gate here: nobody starts Lab B until their dashboard shows Connected and Camera FPS at 55. A board that is not connected after two minutes gets swapped for a spare immediately; helpers carry them. No debugging at the seat in a one-hour format. Inference at zero is expected: the boards arrive with no model.</a:t>
+              <a:t>Gate here: nobody starts Lab B until their dashboard shows Connected and Camera FPS at 55. Each login lives in its own entity, so the attendee sees one device and one dashboard and cannot open the wrong one. A board that is not connected after two minutes gets swapped for a spare immediately, and the helper hands over the spare seat card with it, because the spare lives in its own entity with its own login. No debugging at the seat in a one-hour format. Inference at zero is expected: the boards arrive with no model.</a:t>
             </a:r>
           </a:p>
         </p:txBody>
@@ -1556,7 +1556,7 @@
           <a:lstStyle/>
           <a:p>
             <a:r>
-              <a:t>Do it on the big screen first with your own board: AI Models, Face Detect, Deploy, pick the presenter device, dispatch, and let the room watch the dashboard change. Then let them go. Deploy to your own device only: check the device ID in the dialog before you click. The snapshot is worth a sentence: the board draws the boxes, PNG-encodes the frame and signs the S3 upload itself on the microcontroller. When most of the room has a box on a face, move to Lab C.</a:t>
+              <a:t>Do it on the big screen first with your own board: AI Models, Face Detect, Deploy, pick the presenter device, dispatch, and let the room watch the dashboard change. Then let them go. The deploy dialog shows each attendee exactly one device, their own, because their user lives in an entity that holds only that board. The snapshot is worth a sentence: the board draws the boxes, PNG-encodes the frame and signs the S3 upload itself on the microcontroller. When most of the room has a box on a face, move to Lab C.</a:t>
             </a:r>
           </a:p>
         </p:txBody>
@@ -17270,7 +17270,7 @@
           <a:bodyPr/>
           <a:lstStyle/>
           <a:p>
-            <a:fld id="{B1E6C235-94C9-443F-AD76-87AD7B1BBEA8}" type="slidenum">
+            <a:fld id="{3E50D257-AC57-48D7-86EB-81B5E2E196BA}" type="slidenum">
               <a:rPr lang="en-US"/>
               <a:t>1</a:t>
             </a:fld>
@@ -18275,7 +18275,7 @@
           <a:bodyPr/>
           <a:lstStyle/>
           <a:p>
-            <a:fld id="{A5A4C878-D2F8-4C17-A71D-09A1B276819E}" type="slidenum">
+            <a:fld id="{40FC5F22-C273-4664-B854-1A1B7D9F552D}" type="slidenum">
               <a:rPr lang="en-US"/>
               <a:t>1</a:t>
             </a:fld>
@@ -19374,7 +19374,7 @@
           <a:bodyPr/>
           <a:lstStyle/>
           <a:p>
-            <a:fld id="{781B805A-080F-4E97-871B-EA3C9F8FD1D9}" type="slidenum">
+            <a:fld id="{B63E936F-CCBD-4030-B117-E6E82A10A8C9}" type="slidenum">
               <a:rPr lang="en-US"/>
               <a:t>1</a:t>
             </a:fld>
@@ -20026,7 +20026,7 @@
           <a:bodyPr/>
           <a:lstStyle/>
           <a:p>
-            <a:fld id="{0FFACA5E-9E32-4255-929F-F84897C4017C}" type="slidenum">
+            <a:fld id="{112B4497-F080-4643-BA8D-68D80CB91C79}" type="slidenum">
               <a:rPr lang="en-US"/>
               <a:t>1</a:t>
             </a:fld>
@@ -21368,7 +21368,7 @@
           <a:bodyPr/>
           <a:lstStyle/>
           <a:p>
-            <a:fld id="{F5C3A0C4-D695-4B8C-A4ED-C22544F34E74}" type="slidenum">
+            <a:fld id="{478B2798-15C7-4F41-87AC-FD34A582F05B}" type="slidenum">
               <a:rPr lang="en-US"/>
               <a:t>1</a:t>
             </a:fld>
@@ -21624,7 +21624,7 @@
                 </a:solidFill>
                 <a:latin typeface="Arial"/>
               </a:rPr>
-              <a:t>Leave it as it is. The workshop account closes after the event, so follow the Quickstart to make your own, then erase, reboot and provision it again.</a:t>
+              <a:t>Leave it as it is. The workshop instance is retired after the event, so follow the Quickstart to make your own account, then erase, reboot and provision it again.</a:t>
             </a:r>
           </a:p>
         </p:txBody>
@@ -21788,7 +21788,7 @@
           <a:bodyPr/>
           <a:lstStyle/>
           <a:p>
-            <a:fld id="{6B72B8DA-AEB9-4B48-ABB0-E351E09AE059}" type="slidenum">
+            <a:fld id="{F491EB71-6310-4197-83D4-95BD2DE169EF}" type="slidenum">
               <a:rPr lang="en-US"/>
               <a:t>1</a:t>
             </a:fld>
@@ -22950,7 +22950,7 @@
           <a:bodyPr/>
           <a:lstStyle/>
           <a:p>
-            <a:fld id="{9706C247-EFFB-4652-B586-4B6FFFF7A8C5}" type="slidenum">
+            <a:fld id="{7C70D54B-BA55-4C2D-9E71-952F950A32DD}" type="slidenum">
               <a:rPr lang="en-US"/>
               <a:t>1</a:t>
             </a:fld>
@@ -23336,7 +23336,7 @@
                 </a:solidFill>
                 <a:latin typeface="Arial"/>
               </a:rPr>
-              <a:t>Seat number, your Device ID, the name of your dashboard, and your /IOTCONNECT login. That is all you need today.</a:t>
+              <a:t>Seat number, your login (user-N) and password, and the name of your dashboard. Your login sees exactly one device and one dashboard: yours.</a:t>
             </a:r>
           </a:p>
         </p:txBody>
@@ -23670,7 +23670,7 @@
           <a:bodyPr/>
           <a:lstStyle/>
           <a:p>
-            <a:fld id="{2AE639A4-668F-4EC5-B567-9504A22A1E26}" type="slidenum">
+            <a:fld id="{D25BD655-1DAF-4BDE-822F-122923EC78A8}" type="slidenum">
               <a:rPr lang="en-US"/>
               <a:t>1</a:t>
             </a:fld>
@@ -24200,7 +24200,7 @@
           <a:bodyPr/>
           <a:lstStyle/>
           <a:p>
-            <a:fld id="{549379A7-FAF7-4F25-B414-6281CEAB7EC8}" type="slidenum">
+            <a:fld id="{081FBD79-8C47-4D43-96F0-02725A891DF8}" type="slidenum">
               <a:rPr lang="en-US"/>
               <a:t>1</a:t>
             </a:fld>
@@ -24925,7 +24925,7 @@
           <a:bodyPr/>
           <a:lstStyle/>
           <a:p>
-            <a:fld id="{9FA849BC-3D12-435C-8C1C-B4CD83A24382}" type="slidenum">
+            <a:fld id="{8D019A06-0CF8-4550-AF60-9DE5627F8C58}" type="slidenum">
               <a:rPr lang="en-US"/>
               <a:t>1</a:t>
             </a:fld>
@@ -26223,7 +26223,7 @@
           <a:bodyPr/>
           <a:lstStyle/>
           <a:p>
-            <a:fld id="{FAB348C0-E5F1-40E0-9768-4371AC84FF9C}" type="slidenum">
+            <a:fld id="{9A6CF39F-1ADA-441F-9D5E-0776D96B8809}" type="slidenum">
               <a:rPr lang="en-US"/>
               <a:t>1</a:t>
             </a:fld>
@@ -26296,7 +26296,7 @@
                 </a:solidFill>
                 <a:latin typeface="Arial"/>
               </a:rPr>
-              <a:t>Sign in at console.iotconnect.io with the login on your seat card.</a:t>
+              <a:t>Sign in at console.iotconnect.io as the user on your seat card (user-7, for example).</a:t>
             </a:r>
           </a:p>
           <a:p>
@@ -26320,7 +26320,7 @@
                 </a:solidFill>
                 <a:latin typeface="Arial"/>
               </a:rPr>
-              <a:t>Open Dashboards and pick the one named with your seat, for example Seat 07.</a:t>
+              <a:t>Open Dashboards. There is one, named with your seat. Open it.</a:t>
             </a:r>
           </a:p>
           <a:p>
@@ -26921,7 +26921,7 @@
           <a:bodyPr/>
           <a:lstStyle/>
           <a:p>
-            <a:fld id="{EEFB8A2C-4E28-4860-8CF0-2788745AE9E4}" type="slidenum">
+            <a:fld id="{47CB1E28-C2EA-493B-AFAC-B3A0A0206345}" type="slidenum">
               <a:rPr lang="en-US"/>
               <a:t>1</a:t>
             </a:fld>
@@ -27049,7 +27049,7 @@
                 </a:solidFill>
                 <a:latin typeface="Arial"/>
               </a:rPr>
-              <a:t>AI Models, open RA8P1 Face Detect, choose Deploy, select your device (ek-ra8p1-NN) only, and dispatch.</a:t>
+              <a:t>AI Models, open RA8P1 Face Detect, choose Deploy. Your board is the only device in the list. Select it and dispatch.</a:t>
             </a:r>
           </a:p>
         </p:txBody>

</xml_diff>